<commit_message>
Add hold-out experiment to architecture docs and slides.
Co-authored-by: Cursor <cursoragent@cursor.com>
</commit_message>
<xml_diff>
--- a/docs/DengueCAD_Architecture_Slides.pptx
+++ b/docs/DengueCAD_Architecture_Slides.pptx
@@ -19,6 +19,7 @@
     <p:sldId id="267" r:id="rId19"/>
     <p:sldId id="268" r:id="rId20"/>
     <p:sldId id="269" r:id="rId21"/>
+    <p:sldId id="270" r:id="rId22"/>
   </p:sldIdLst>
   <p:sldSz cx="12191695" cy="6858000" type="screen4x3"/>
   <p:notesSz cx="6858000" cy="9144000"/>
@@ -655,7 +656,7 @@
           <a:lstStyle/>
           <a:p>
             <a:r>
-              <a:t>results/ is git-ignored; the PDF report is the committed record of performance.</a:t>
+              <a:t>Run on five dengue datasets and eleven disease ARFFs, 10 seeds each (3 for the 70k dengue.csv sample). Tables 1.1 and 2.1 score imputation of the masked cells, 1.2 and 2.2 score prediction of the hidden decisions. Results are in DengueCAD_Imputation_Prediction_Holdout.pdf.</a:t>
             </a:r>
           </a:p>
         </p:txBody>
@@ -725,7 +726,7 @@
           <a:lstStyle/>
           <a:p>
             <a:r>
-              <a:t>The same gates run locally with scripts/ci_local.sh before pushing. System tests clone the NMI library and use the datasets in data/.</a:t>
+              <a:t>results/ is git-ignored; the PDF report is the committed record of performance.</a:t>
             </a:r>
           </a:p>
         </p:txBody>
@@ -795,7 +796,7 @@
           <a:lstStyle/>
           <a:p>
             <a:r>
-              <a:t>These are the seams to use when adding a disease dataset, a new imputer or a new classifier.</a:t>
+              <a:t>The same gates run locally with scripts/ci_local.sh before pushing. System tests clone the NMI library and use the datasets in data/.</a:t>
             </a:r>
           </a:p>
         </p:txBody>
@@ -865,6 +866,76 @@
           <a:lstStyle/>
           <a:p>
             <a:r>
+              <a:t>These are the seams to use when adding a disease dataset, a new imputer or a new classifier.</a:t>
+            </a:r>
+          </a:p>
+        </p:txBody>
+      </p:sp>
+      <p:sp>
+        <p:nvSpPr>
+          <p:cNvPr id="4" name="Slide Number Placeholder 3"/>
+          <p:cNvSpPr>
+            <a:spLocks noGrp="1"/>
+          </p:cNvSpPr>
+          <p:nvPr>
+            <p:ph type="sldNum" idx="5" sz="quarter"/>
+          </p:nvPr>
+        </p:nvSpPr>
+        <p:spPr/>
+      </p:sp>
+    </p:spTree>
+  </p:cSld>
+  <p:clrMapOvr>
+    <a:masterClrMapping/>
+  </p:clrMapOvr>
+</p:notes>
+</file>
+
+<file path=ppt/notesSlides/notesSlide15.xml><?xml version="1.0" encoding="utf-8"?>
+<p:notes xmlns:a="http://schemas.openxmlformats.org/drawingml/2006/main" xmlns:p="http://schemas.openxmlformats.org/presentationml/2006/main" xmlns:r="http://schemas.openxmlformats.org/officeDocument/2006/relationships">
+  <p:cSld>
+    <p:spTree>
+      <p:nvGrpSpPr>
+        <p:cNvPr id="1" name=""/>
+        <p:cNvGrpSpPr/>
+        <p:nvPr/>
+      </p:nvGrpSpPr>
+      <p:grpSpPr>
+        <a:xfrm>
+          <a:off x="0" y="0"/>
+          <a:ext cx="0" cy="0"/>
+          <a:chOff x="0" y="0"/>
+          <a:chExt cx="0" cy="0"/>
+        </a:xfrm>
+      </p:grpSpPr>
+      <p:sp>
+        <p:nvSpPr>
+          <p:cNvPr id="2" name="Slide Image Placeholder 1"/>
+          <p:cNvSpPr>
+            <a:spLocks noGrp="1"/>
+          </p:cNvSpPr>
+          <p:nvPr>
+            <p:ph type="sldImg" idx="2"/>
+          </p:nvPr>
+        </p:nvSpPr>
+        <p:spPr/>
+      </p:sp>
+      <p:sp>
+        <p:nvSpPr>
+          <p:cNvPr id="3" name="Notes Placeholder 2"/>
+          <p:cNvSpPr>
+            <a:spLocks noGrp="1"/>
+          </p:cNvSpPr>
+          <p:nvPr>
+            <p:ph type="body" idx="3" sz="quarter"/>
+          </p:nvPr>
+        </p:nvSpPr>
+        <p:spPr/>
+        <p:txBody>
+          <a:bodyPr/>
+          <a:lstStyle/>
+          <a:p>
+            <a:r>
               <a:t>Diagrams live as Mermaid in docs/ARCHITECTURE.md; images and slides are generated.</a:t>
             </a:r>
           </a:p>
@@ -1285,7 +1356,7 @@
           <a:lstStyle/>
           <a:p>
             <a:r>
-              <a:t>comparison orchestrates NM and baselines. nm_prediction depends on feature_selection, baselines, metrics and nmi_support. adt is shared by baselines and the GA classifier factory.</a:t>
+              <a:t>comparison orchestrates NM and baselines; holdout_experiment reuses nm_prediction, the imputers and the baselines. nm_prediction depends on feature_selection, baselines, metrics and nmi_support. adt is shared by baselines and the GA classifier factory.</a:t>
             </a:r>
           </a:p>
         </p:txBody>
@@ -4552,7 +4623,7 @@
                   <a:srgbClr val="A0AEC0"/>
                 </a:solidFill>
               </a:rPr>
-              <a:t>September 2026</a:t>
+              <a:t>October 2026</a:t>
             </a:r>
           </a:p>
         </p:txBody>
@@ -4782,7 +4853,7 @@
                   <a:srgbClr val="FFFFFF"/>
                 </a:solidFill>
               </a:rPr>
-              <a:t>Experiment runners and outputs</a:t>
+              <a:t>Imputation + prediction hold-out experiment</a:t>
             </a:r>
             <a:r>
               <a:rPr sz="1600">
@@ -4790,609 +4861,72 @@
                   <a:srgbClr val="BEE3F8"/>
                 </a:solidFill>
               </a:rPr>
-              <a:t>   scripts/ → results/</a:t>
-            </a:r>
-          </a:p>
-        </p:txBody>
-      </p:sp>
-      <p:graphicFrame>
-        <p:nvGraphicFramePr>
-          <p:cNvPr id="3" name="Table 2"/>
-          <p:cNvGraphicFramePr>
-            <a:graphicFrameLocks noGrp="1"/>
-          </p:cNvGraphicFramePr>
+              <a:t>   holdout_experiment.py</a:t>
+            </a:r>
+          </a:p>
+        </p:txBody>
+      </p:sp>
+      <p:pic>
+        <p:nvPicPr>
+          <p:cNvPr id="3" name="Picture 2" descr="09-holdout-protocol.png"/>
+          <p:cNvPicPr>
+            <a:picLocks noChangeAspect="1"/>
+          </p:cNvPicPr>
           <p:nvPr/>
-        </p:nvGraphicFramePr>
-        <p:xfrm>
-          <a:off x="274320" y="1280160"/>
-          <a:ext cx="11643053" cy="4389120"/>
-        </p:xfrm>
-        <a:graphic>
-          <a:graphicData uri="http://schemas.openxmlformats.org/drawingml/2006/table">
-            <a:tbl>
-              <a:tblPr firstRow="1" bandRow="1">
-                <a:tableStyleId>{5C22544A-7EE6-4342-B048-85BDC9FD1C3A}</a:tableStyleId>
-              </a:tblPr>
-              <a:tblGrid>
-                <a:gridCol w="3514884"/>
-                <a:gridCol w="3514884"/>
-                <a:gridCol w="4613285"/>
-              </a:tblGrid>
-              <a:tr h="548640">
-                <a:tc>
-                  <a:txBody>
-                    <a:bodyPr/>
-                    <a:lstStyle/>
-                    <a:p>
-                      <a:pPr>
-                        <a:defRPr sz="1700" b="1">
-                          <a:solidFill>
-                            <a:srgbClr val="FFFFFF"/>
-                          </a:solidFill>
-                        </a:defRPr>
-                      </a:pPr>
-                      <a:r>
-                        <a:t>Script</a:t>
-                      </a:r>
-                    </a:p>
-                  </a:txBody>
-                  <a:tcPr>
-                    <a:solidFill>
-                      <a:srgbClr val="2C5282"/>
-                    </a:solidFill>
-                  </a:tcPr>
-                </a:tc>
-                <a:tc>
-                  <a:txBody>
-                    <a:bodyPr/>
-                    <a:lstStyle/>
-                    <a:p>
-                      <a:pPr>
-                        <a:defRPr sz="1700" b="1">
-                          <a:solidFill>
-                            <a:srgbClr val="FFFFFF"/>
-                          </a:solidFill>
-                        </a:defRPr>
-                      </a:pPr>
-                      <a:r>
-                        <a:t>Dataset</a:t>
-                      </a:r>
-                    </a:p>
-                  </a:txBody>
-                  <a:tcPr>
-                    <a:solidFill>
-                      <a:srgbClr val="2C5282"/>
-                    </a:solidFill>
-                  </a:tcPr>
-                </a:tc>
-                <a:tc>
-                  <a:txBody>
-                    <a:bodyPr/>
-                    <a:lstStyle/>
-                    <a:p>
-                      <a:pPr>
-                        <a:defRPr sz="1700" b="1">
-                          <a:solidFill>
-                            <a:srgbClr val="FFFFFF"/>
-                          </a:solidFill>
-                        </a:defRPr>
-                      </a:pPr>
-                      <a:r>
-                        <a:t>Output</a:t>
-                      </a:r>
-                    </a:p>
-                  </a:txBody>
-                  <a:tcPr>
-                    <a:solidFill>
-                      <a:srgbClr val="2C5282"/>
-                    </a:solidFill>
-                  </a:tcPr>
-                </a:tc>
-              </a:tr>
-              <a:tr h="548640">
-                <a:tc>
-                  <a:txBody>
-                    <a:bodyPr/>
-                    <a:lstStyle/>
-                    <a:p>
-                      <a:pPr>
-                        <a:defRPr sz="1700" b="0">
-                          <a:solidFill>
-                            <a:srgbClr val="1A365D"/>
-                          </a:solidFill>
-                        </a:defRPr>
-                      </a:pPr>
-                      <a:r>
-                        <a:t>run_nm_comparison.py</a:t>
-                      </a:r>
-                    </a:p>
-                  </a:txBody>
-                  <a:tcPr>
-                    <a:solidFill>
-                      <a:srgbClr val="EBF4FF"/>
-                    </a:solidFill>
-                  </a:tcPr>
-                </a:tc>
-                <a:tc>
-                  <a:txBody>
-                    <a:bodyPr/>
-                    <a:lstStyle/>
-                    <a:p>
-                      <a:pPr>
-                        <a:defRPr sz="1700" b="0">
-                          <a:solidFill>
-                            <a:srgbClr val="1A365D"/>
-                          </a:solidFill>
-                        </a:defRPr>
-                      </a:pPr>
-                      <a:r>
-                        <a:t>dengue.csv (70k / 10k / 20k)</a:t>
-                      </a:r>
-                    </a:p>
-                  </a:txBody>
-                  <a:tcPr>
-                    <a:solidFill>
-                      <a:srgbClr val="EBF4FF"/>
-                    </a:solidFill>
-                  </a:tcPr>
-                </a:tc>
-                <a:tc>
-                  <a:txBody>
-                    <a:bodyPr/>
-                    <a:lstStyle/>
-                    <a:p>
-                      <a:pPr>
-                        <a:defRPr sz="1700" b="0">
-                          <a:solidFill>
-                            <a:srgbClr val="1A365D"/>
-                          </a:solidFill>
-                        </a:defRPr>
-                      </a:pPr>
-                      <a:r>
-                        <a:t>Tables I–III, hold-out metrics, split summary</a:t>
-                      </a:r>
-                    </a:p>
-                  </a:txBody>
-                  <a:tcPr>
-                    <a:solidFill>
-                      <a:srgbClr val="EBF4FF"/>
-                    </a:solidFill>
-                  </a:tcPr>
-                </a:tc>
-              </a:tr>
-              <a:tr h="548640">
-                <a:tc>
-                  <a:txBody>
-                    <a:bodyPr/>
-                    <a:lstStyle/>
-                    <a:p>
-                      <a:pPr>
-                        <a:defRPr sz="1700" b="0">
-                          <a:solidFill>
-                            <a:srgbClr val="1A365D"/>
-                          </a:solidFill>
-                        </a:defRPr>
-                      </a:pPr>
-                      <a:r>
-                        <a:t>run_nm_on_dataset_csv.py</a:t>
-                      </a:r>
-                    </a:p>
-                  </a:txBody>
-                  <a:tcPr>
-                    <a:solidFill>
-                      <a:srgbClr val="FFFFFF"/>
-                    </a:solidFill>
-                  </a:tcPr>
-                </a:tc>
-                <a:tc>
-                  <a:txBody>
-                    <a:bodyPr/>
-                    <a:lstStyle/>
-                    <a:p>
-                      <a:pPr>
-                        <a:defRPr sz="1700" b="0">
-                          <a:solidFill>
-                            <a:srgbClr val="1A365D"/>
-                          </a:solidFill>
-                        </a:defRPr>
-                      </a:pPr>
-                      <a:r>
-                        <a:t>dataset.csv (Bangladesh)</a:t>
-                      </a:r>
-                    </a:p>
-                  </a:txBody>
-                  <a:tcPr>
-                    <a:solidFill>
-                      <a:srgbClr val="FFFFFF"/>
-                    </a:solidFill>
-                  </a:tcPr>
-                </a:tc>
-                <a:tc>
-                  <a:txBody>
-                    <a:bodyPr/>
-                    <a:lstStyle/>
-                    <a:p>
-                      <a:pPr>
-                        <a:defRPr sz="1700" b="0">
-                          <a:solidFill>
-                            <a:srgbClr val="1A365D"/>
-                          </a:solidFill>
-                        </a:defRPr>
-                      </a:pPr>
-                      <a:r>
-                        <a:t>results/nmprediction_dataset_csv/</a:t>
-                      </a:r>
-                    </a:p>
-                  </a:txBody>
-                  <a:tcPr>
-                    <a:solidFill>
-                      <a:srgbClr val="FFFFFF"/>
-                    </a:solidFill>
-                  </a:tcPr>
-                </a:tc>
-              </a:tr>
-              <a:tr h="548640">
-                <a:tc>
-                  <a:txBody>
-                    <a:bodyPr/>
-                    <a:lstStyle/>
-                    <a:p>
-                      <a:pPr>
-                        <a:defRPr sz="1700" b="0">
-                          <a:solidFill>
-                            <a:srgbClr val="1A365D"/>
-                          </a:solidFill>
-                        </a:defRPr>
-                      </a:pPr>
-                      <a:r>
-                        <a:t>run_nm_on_clinical.py</a:t>
-                      </a:r>
-                    </a:p>
-                  </a:txBody>
-                  <a:tcPr>
-                    <a:solidFill>
-                      <a:srgbClr val="EBF4FF"/>
-                    </a:solidFill>
-                  </a:tcPr>
-                </a:tc>
-                <a:tc>
-                  <a:txBody>
-                    <a:bodyPr/>
-                    <a:lstStyle/>
-                    <a:p>
-                      <a:pPr>
-                        <a:defRPr sz="1700" b="0">
-                          <a:solidFill>
-                            <a:srgbClr val="1A365D"/>
-                          </a:solidFill>
-                        </a:defRPr>
-                      </a:pPr>
-                      <a:r>
-                        <a:t>Dengue_clinical_dataset.csv</a:t>
-                      </a:r>
-                    </a:p>
-                  </a:txBody>
-                  <a:tcPr>
-                    <a:solidFill>
-                      <a:srgbClr val="EBF4FF"/>
-                    </a:solidFill>
-                  </a:tcPr>
-                </a:tc>
-                <a:tc>
-                  <a:txBody>
-                    <a:bodyPr/>
-                    <a:lstStyle/>
-                    <a:p>
-                      <a:pPr>
-                        <a:defRPr sz="1700" b="0">
-                          <a:solidFill>
-                            <a:srgbClr val="1A365D"/>
-                          </a:solidFill>
-                        </a:defRPr>
-                      </a:pPr>
-                      <a:r>
-                        <a:t>results/nmprediction_clinical/</a:t>
-                      </a:r>
-                    </a:p>
-                  </a:txBody>
-                  <a:tcPr>
-                    <a:solidFill>
-                      <a:srgbClr val="EBF4FF"/>
-                    </a:solidFill>
-                  </a:tcPr>
-                </a:tc>
-              </a:tr>
-              <a:tr h="548640">
-                <a:tc>
-                  <a:txBody>
-                    <a:bodyPr/>
-                    <a:lstStyle/>
-                    <a:p>
-                      <a:pPr>
-                        <a:defRPr sz="1700" b="0">
-                          <a:solidFill>
-                            <a:srgbClr val="1A365D"/>
-                          </a:solidFill>
-                        </a:defRPr>
-                      </a:pPr>
-                      <a:r>
-                        <a:t>run_arff_disease_benchmark.py</a:t>
-                      </a:r>
-                    </a:p>
-                  </a:txBody>
-                  <a:tcPr>
-                    <a:solidFill>
-                      <a:srgbClr val="FFFFFF"/>
-                    </a:solidFill>
-                  </a:tcPr>
-                </a:tc>
-                <a:tc>
-                  <a:txBody>
-                    <a:bodyPr/>
-                    <a:lstStyle/>
-                    <a:p>
-                      <a:pPr>
-                        <a:defRPr sz="1700" b="0">
-                          <a:solidFill>
-                            <a:srgbClr val="1A365D"/>
-                          </a:solidFill>
-                        </a:defRPr>
-                      </a:pPr>
-                      <a:r>
-                        <a:t>11 disease ARFFs</a:t>
-                      </a:r>
-                    </a:p>
-                  </a:txBody>
-                  <a:tcPr>
-                    <a:solidFill>
-                      <a:srgbClr val="FFFFFF"/>
-                    </a:solidFill>
-                  </a:tcPr>
-                </a:tc>
-                <a:tc>
-                  <a:txBody>
-                    <a:bodyPr/>
-                    <a:lstStyle/>
-                    <a:p>
-                      <a:pPr>
-                        <a:defRPr sz="1700" b="0">
-                          <a:solidFill>
-                            <a:srgbClr val="1A365D"/>
-                          </a:solidFill>
-                        </a:defRPr>
-                      </a:pPr>
-                      <a:r>
-                        <a:t>results/arff_disease_comparison/</a:t>
-                      </a:r>
-                    </a:p>
-                  </a:txBody>
-                  <a:tcPr>
-                    <a:solidFill>
-                      <a:srgbClr val="FFFFFF"/>
-                    </a:solidFill>
-                  </a:tcPr>
-                </a:tc>
-              </a:tr>
-              <a:tr h="548640">
-                <a:tc>
-                  <a:txBody>
-                    <a:bodyPr/>
-                    <a:lstStyle/>
-                    <a:p>
-                      <a:pPr>
-                        <a:defRPr sz="1700" b="0">
-                          <a:solidFill>
-                            <a:srgbClr val="1A365D"/>
-                          </a:solidFill>
-                        </a:defRPr>
-                      </a:pPr>
-                      <a:r>
-                        <a:t>run_imputation_comparison.py</a:t>
-                      </a:r>
-                    </a:p>
-                  </a:txBody>
-                  <a:tcPr>
-                    <a:solidFill>
-                      <a:srgbClr val="EBF4FF"/>
-                    </a:solidFill>
-                  </a:tcPr>
-                </a:tc>
-                <a:tc>
-                  <a:txBody>
-                    <a:bodyPr/>
-                    <a:lstStyle/>
-                    <a:p>
-                      <a:pPr>
-                        <a:defRPr sz="1700" b="0">
-                          <a:solidFill>
-                            <a:srgbClr val="1A365D"/>
-                          </a:solidFill>
-                        </a:defRPr>
-                      </a:pPr>
-                      <a:r>
-                        <a:t>dataset.csv + MCAR</a:t>
-                      </a:r>
-                    </a:p>
-                  </a:txBody>
-                  <a:tcPr>
-                    <a:solidFill>
-                      <a:srgbClr val="EBF4FF"/>
-                    </a:solidFill>
-                  </a:tcPr>
-                </a:tc>
-                <a:tc>
-                  <a:txBody>
-                    <a:bodyPr/>
-                    <a:lstStyle/>
-                    <a:p>
-                      <a:pPr>
-                        <a:defRPr sz="1700" b="0">
-                          <a:solidFill>
-                            <a:srgbClr val="1A365D"/>
-                          </a:solidFill>
-                        </a:defRPr>
-                      </a:pPr>
-                      <a:r>
-                        <a:t>results/imputation_dataset_csv/</a:t>
-                      </a:r>
-                    </a:p>
-                  </a:txBody>
-                  <a:tcPr>
-                    <a:solidFill>
-                      <a:srgbClr val="EBF4FF"/>
-                    </a:solidFill>
-                  </a:tcPr>
-                </a:tc>
-              </a:tr>
-              <a:tr h="548640">
-                <a:tc>
-                  <a:txBody>
-                    <a:bodyPr/>
-                    <a:lstStyle/>
-                    <a:p>
-                      <a:pPr>
-                        <a:defRPr sz="1700" b="0">
-                          <a:solidFill>
-                            <a:srgbClr val="1A365D"/>
-                          </a:solidFill>
-                        </a:defRPr>
-                      </a:pPr>
-                      <a:r>
-                        <a:t>run_missforest_comparison.py</a:t>
-                      </a:r>
-                    </a:p>
-                  </a:txBody>
-                  <a:tcPr>
-                    <a:solidFill>
-                      <a:srgbClr val="FFFFFF"/>
-                    </a:solidFill>
-                  </a:tcPr>
-                </a:tc>
-                <a:tc>
-                  <a:txBody>
-                    <a:bodyPr/>
-                    <a:lstStyle/>
-                    <a:p>
-                      <a:pPr>
-                        <a:defRPr sz="1700" b="0">
-                          <a:solidFill>
-                            <a:srgbClr val="1A365D"/>
-                          </a:solidFill>
-                        </a:defRPr>
-                      </a:pPr>
-                      <a:r>
-                        <a:t>Iris + 20% MCAR</a:t>
-                      </a:r>
-                    </a:p>
-                  </a:txBody>
-                  <a:tcPr>
-                    <a:solidFill>
-                      <a:srgbClr val="FFFFFF"/>
-                    </a:solidFill>
-                  </a:tcPr>
-                </a:tc>
-                <a:tc>
-                  <a:txBody>
-                    <a:bodyPr/>
-                    <a:lstStyle/>
-                    <a:p>
-                      <a:pPr>
-                        <a:defRPr sz="1700" b="0">
-                          <a:solidFill>
-                            <a:srgbClr val="1A365D"/>
-                          </a:solidFill>
-                        </a:defRPr>
-                      </a:pPr>
-                      <a:r>
-                        <a:t>results/missforest_comparison/</a:t>
-                      </a:r>
-                    </a:p>
-                  </a:txBody>
-                  <a:tcPr>
-                    <a:solidFill>
-                      <a:srgbClr val="FFFFFF"/>
-                    </a:solidFill>
-                  </a:tcPr>
-                </a:tc>
-              </a:tr>
-              <a:tr h="548640">
-                <a:tc>
-                  <a:txBody>
-                    <a:bodyPr/>
-                    <a:lstStyle/>
-                    <a:p>
-                      <a:pPr>
-                        <a:defRPr sz="1700" b="0">
-                          <a:solidFill>
-                            <a:srgbClr val="1A365D"/>
-                          </a:solidFill>
-                        </a:defRPr>
-                      </a:pPr>
-                      <a:r>
-                        <a:t>build_comparison_pdf.py</a:t>
-                      </a:r>
-                    </a:p>
-                  </a:txBody>
-                  <a:tcPr>
-                    <a:solidFill>
-                      <a:srgbClr val="EBF4FF"/>
-                    </a:solidFill>
-                  </a:tcPr>
-                </a:tc>
-                <a:tc>
-                  <a:txBody>
-                    <a:bodyPr/>
-                    <a:lstStyle/>
-                    <a:p>
-                      <a:pPr>
-                        <a:defRPr sz="1700" b="0">
-                          <a:solidFill>
-                            <a:srgbClr val="1A365D"/>
-                          </a:solidFill>
-                        </a:defRPr>
-                      </a:pPr>
-                      <a:r>
-                        <a:t>all results</a:t>
-                      </a:r>
-                    </a:p>
-                  </a:txBody>
-                  <a:tcPr>
-                    <a:solidFill>
-                      <a:srgbClr val="EBF4FF"/>
-                    </a:solidFill>
-                  </a:tcPr>
-                </a:tc>
-                <a:tc>
-                  <a:txBody>
-                    <a:bodyPr/>
-                    <a:lstStyle/>
-                    <a:p>
-                      <a:pPr>
-                        <a:defRPr sz="1700" b="0">
-                          <a:solidFill>
-                            <a:srgbClr val="1A365D"/>
-                          </a:solidFill>
-                        </a:defRPr>
-                      </a:pPr>
-                      <a:r>
-                        <a:t>Performance comparison PDF (docs/)</a:t>
-                      </a:r>
-                    </a:p>
-                  </a:txBody>
-                  <a:tcPr>
-                    <a:solidFill>
-                      <a:srgbClr val="EBF4FF"/>
-                    </a:solidFill>
-                  </a:tcPr>
-                </a:tc>
-              </a:tr>
-            </a:tbl>
-          </a:graphicData>
-        </a:graphic>
-      </p:graphicFrame>
+        </p:nvPicPr>
+        <p:blipFill>
+          <a:blip r:embed="rId2"/>
+          <a:stretch>
+            <a:fillRect/>
+          </a:stretch>
+        </p:blipFill>
+        <p:spPr>
+          <a:xfrm>
+            <a:off x="2329823" y="914400"/>
+            <a:ext cx="7532048" cy="5120640"/>
+          </a:xfrm>
+          <a:prstGeom prst="rect">
+            <a:avLst/>
+          </a:prstGeom>
+        </p:spPr>
+      </p:pic>
       <p:sp>
         <p:nvSpPr>
           <p:cNvPr id="4" name="TextBox 3"/>
+          <p:cNvSpPr txBox="1"/>
+          <p:nvPr/>
+        </p:nvSpPr>
+        <p:spPr>
+          <a:xfrm>
+            <a:off x="274320" y="6080760"/>
+            <a:ext cx="11643055" cy="457200"/>
+          </a:xfrm>
+          <a:prstGeom prst="rect">
+            <a:avLst/>
+          </a:prstGeom>
+          <a:noFill/>
+        </p:spPr>
+        <p:txBody>
+          <a:bodyPr wrap="square">
+            <a:spAutoFit/>
+          </a:bodyPr>
+          <a:lstStyle/>
+          <a:p>
+            <a:pPr algn="ctr"/>
+            <a:r>
+              <a:rPr sz="1400" i="1">
+                <a:solidFill>
+                  <a:srgbClr val="4A5568"/>
+                </a:solidFill>
+              </a:rPr>
+              <a:t>valid_set kept aside · 20% of records masked and imputed · NMI-imputed train_set · decisions hidden on 20% of a 30% hold-out and predicted.</a:t>
+            </a:r>
+          </a:p>
+        </p:txBody>
+      </p:sp>
+      <p:sp>
+        <p:nvSpPr>
+          <p:cNvPr id="5" name="TextBox 4"/>
           <p:cNvSpPr txBox="1"/>
           <p:nvPr/>
         </p:nvSpPr>
@@ -5488,7 +5022,7 @@
                   <a:srgbClr val="FFFFFF"/>
                 </a:solidFill>
               </a:rPr>
-              <a:t>CI/CD</a:t>
+              <a:t>Experiment runners and outputs</a:t>
             </a:r>
             <a:r>
               <a:rPr sz="1600">
@@ -5496,72 +5030,751 @@
                   <a:srgbClr val="BEE3F8"/>
                 </a:solidFill>
               </a:rPr>
-              <a:t>   GitHub Actions</a:t>
-            </a:r>
-          </a:p>
-        </p:txBody>
-      </p:sp>
-      <p:pic>
-        <p:nvPicPr>
-          <p:cNvPr id="3" name="Picture 2" descr="08-ci-cd.png"/>
-          <p:cNvPicPr>
-            <a:picLocks noChangeAspect="1"/>
-          </p:cNvPicPr>
+              <a:t>   scripts/ → results/</a:t>
+            </a:r>
+          </a:p>
+        </p:txBody>
+      </p:sp>
+      <p:graphicFrame>
+        <p:nvGraphicFramePr>
+          <p:cNvPr id="3" name="Table 2"/>
+          <p:cNvGraphicFramePr>
+            <a:graphicFrameLocks noGrp="1"/>
+          </p:cNvGraphicFramePr>
           <p:nvPr/>
-        </p:nvPicPr>
-        <p:blipFill>
-          <a:blip r:embed="rId2"/>
-          <a:stretch>
-            <a:fillRect/>
-          </a:stretch>
-        </p:blipFill>
-        <p:spPr>
-          <a:xfrm>
-            <a:off x="274320" y="2390609"/>
-            <a:ext cx="11643055" cy="2168221"/>
-          </a:xfrm>
-          <a:prstGeom prst="rect">
-            <a:avLst/>
-          </a:prstGeom>
-        </p:spPr>
-      </p:pic>
+        </p:nvGraphicFramePr>
+        <p:xfrm>
+          <a:off x="274320" y="1143000"/>
+          <a:ext cx="11643054" cy="4572000"/>
+        </p:xfrm>
+        <a:graphic>
+          <a:graphicData uri="http://schemas.openxmlformats.org/drawingml/2006/table">
+            <a:tbl>
+              <a:tblPr firstRow="1" bandRow="1">
+                <a:tableStyleId>{5C22544A-7EE6-4342-B048-85BDC9FD1C3A}</a:tableStyleId>
+              </a:tblPr>
+              <a:tblGrid>
+                <a:gridCol w="3954245"/>
+                <a:gridCol w="3295204"/>
+                <a:gridCol w="4393605"/>
+              </a:tblGrid>
+              <a:tr h="457200">
+                <a:tc>
+                  <a:txBody>
+                    <a:bodyPr/>
+                    <a:lstStyle/>
+                    <a:p>
+                      <a:pPr>
+                        <a:defRPr sz="1500" b="1">
+                          <a:solidFill>
+                            <a:srgbClr val="FFFFFF"/>
+                          </a:solidFill>
+                        </a:defRPr>
+                      </a:pPr>
+                      <a:r>
+                        <a:t>Script</a:t>
+                      </a:r>
+                    </a:p>
+                  </a:txBody>
+                  <a:tcPr>
+                    <a:solidFill>
+                      <a:srgbClr val="2C5282"/>
+                    </a:solidFill>
+                  </a:tcPr>
+                </a:tc>
+                <a:tc>
+                  <a:txBody>
+                    <a:bodyPr/>
+                    <a:lstStyle/>
+                    <a:p>
+                      <a:pPr>
+                        <a:defRPr sz="1500" b="1">
+                          <a:solidFill>
+                            <a:srgbClr val="FFFFFF"/>
+                          </a:solidFill>
+                        </a:defRPr>
+                      </a:pPr>
+                      <a:r>
+                        <a:t>Dataset</a:t>
+                      </a:r>
+                    </a:p>
+                  </a:txBody>
+                  <a:tcPr>
+                    <a:solidFill>
+                      <a:srgbClr val="2C5282"/>
+                    </a:solidFill>
+                  </a:tcPr>
+                </a:tc>
+                <a:tc>
+                  <a:txBody>
+                    <a:bodyPr/>
+                    <a:lstStyle/>
+                    <a:p>
+                      <a:pPr>
+                        <a:defRPr sz="1500" b="1">
+                          <a:solidFill>
+                            <a:srgbClr val="FFFFFF"/>
+                          </a:solidFill>
+                        </a:defRPr>
+                      </a:pPr>
+                      <a:r>
+                        <a:t>Output</a:t>
+                      </a:r>
+                    </a:p>
+                  </a:txBody>
+                  <a:tcPr>
+                    <a:solidFill>
+                      <a:srgbClr val="2C5282"/>
+                    </a:solidFill>
+                  </a:tcPr>
+                </a:tc>
+              </a:tr>
+              <a:tr h="457200">
+                <a:tc>
+                  <a:txBody>
+                    <a:bodyPr/>
+                    <a:lstStyle/>
+                    <a:p>
+                      <a:pPr>
+                        <a:defRPr sz="1500" b="0">
+                          <a:solidFill>
+                            <a:srgbClr val="1A365D"/>
+                          </a:solidFill>
+                        </a:defRPr>
+                      </a:pPr>
+                      <a:r>
+                        <a:t>run_nm_comparison.py</a:t>
+                      </a:r>
+                    </a:p>
+                  </a:txBody>
+                  <a:tcPr>
+                    <a:solidFill>
+                      <a:srgbClr val="EBF4FF"/>
+                    </a:solidFill>
+                  </a:tcPr>
+                </a:tc>
+                <a:tc>
+                  <a:txBody>
+                    <a:bodyPr/>
+                    <a:lstStyle/>
+                    <a:p>
+                      <a:pPr>
+                        <a:defRPr sz="1500" b="0">
+                          <a:solidFill>
+                            <a:srgbClr val="1A365D"/>
+                          </a:solidFill>
+                        </a:defRPr>
+                      </a:pPr>
+                      <a:r>
+                        <a:t>dengue.csv (70k / 10k / 20k)</a:t>
+                      </a:r>
+                    </a:p>
+                  </a:txBody>
+                  <a:tcPr>
+                    <a:solidFill>
+                      <a:srgbClr val="EBF4FF"/>
+                    </a:solidFill>
+                  </a:tcPr>
+                </a:tc>
+                <a:tc>
+                  <a:txBody>
+                    <a:bodyPr/>
+                    <a:lstStyle/>
+                    <a:p>
+                      <a:pPr>
+                        <a:defRPr sz="1500" b="0">
+                          <a:solidFill>
+                            <a:srgbClr val="1A365D"/>
+                          </a:solidFill>
+                        </a:defRPr>
+                      </a:pPr>
+                      <a:r>
+                        <a:t>Tables I–III, hold-out metrics, split summary</a:t>
+                      </a:r>
+                    </a:p>
+                  </a:txBody>
+                  <a:tcPr>
+                    <a:solidFill>
+                      <a:srgbClr val="EBF4FF"/>
+                    </a:solidFill>
+                  </a:tcPr>
+                </a:tc>
+              </a:tr>
+              <a:tr h="457200">
+                <a:tc>
+                  <a:txBody>
+                    <a:bodyPr/>
+                    <a:lstStyle/>
+                    <a:p>
+                      <a:pPr>
+                        <a:defRPr sz="1500" b="0">
+                          <a:solidFill>
+                            <a:srgbClr val="1A365D"/>
+                          </a:solidFill>
+                        </a:defRPr>
+                      </a:pPr>
+                      <a:r>
+                        <a:t>run_nm_on_dataset_csv.py</a:t>
+                      </a:r>
+                    </a:p>
+                  </a:txBody>
+                  <a:tcPr>
+                    <a:solidFill>
+                      <a:srgbClr val="FFFFFF"/>
+                    </a:solidFill>
+                  </a:tcPr>
+                </a:tc>
+                <a:tc>
+                  <a:txBody>
+                    <a:bodyPr/>
+                    <a:lstStyle/>
+                    <a:p>
+                      <a:pPr>
+                        <a:defRPr sz="1500" b="0">
+                          <a:solidFill>
+                            <a:srgbClr val="1A365D"/>
+                          </a:solidFill>
+                        </a:defRPr>
+                      </a:pPr>
+                      <a:r>
+                        <a:t>dataset.csv (Bangladesh)</a:t>
+                      </a:r>
+                    </a:p>
+                  </a:txBody>
+                  <a:tcPr>
+                    <a:solidFill>
+                      <a:srgbClr val="FFFFFF"/>
+                    </a:solidFill>
+                  </a:tcPr>
+                </a:tc>
+                <a:tc>
+                  <a:txBody>
+                    <a:bodyPr/>
+                    <a:lstStyle/>
+                    <a:p>
+                      <a:pPr>
+                        <a:defRPr sz="1500" b="0">
+                          <a:solidFill>
+                            <a:srgbClr val="1A365D"/>
+                          </a:solidFill>
+                        </a:defRPr>
+                      </a:pPr>
+                      <a:r>
+                        <a:t>results/nmprediction_dataset_csv/</a:t>
+                      </a:r>
+                    </a:p>
+                  </a:txBody>
+                  <a:tcPr>
+                    <a:solidFill>
+                      <a:srgbClr val="FFFFFF"/>
+                    </a:solidFill>
+                  </a:tcPr>
+                </a:tc>
+              </a:tr>
+              <a:tr h="457200">
+                <a:tc>
+                  <a:txBody>
+                    <a:bodyPr/>
+                    <a:lstStyle/>
+                    <a:p>
+                      <a:pPr>
+                        <a:defRPr sz="1500" b="0">
+                          <a:solidFill>
+                            <a:srgbClr val="1A365D"/>
+                          </a:solidFill>
+                        </a:defRPr>
+                      </a:pPr>
+                      <a:r>
+                        <a:t>run_nm_on_clinical.py</a:t>
+                      </a:r>
+                    </a:p>
+                  </a:txBody>
+                  <a:tcPr>
+                    <a:solidFill>
+                      <a:srgbClr val="EBF4FF"/>
+                    </a:solidFill>
+                  </a:tcPr>
+                </a:tc>
+                <a:tc>
+                  <a:txBody>
+                    <a:bodyPr/>
+                    <a:lstStyle/>
+                    <a:p>
+                      <a:pPr>
+                        <a:defRPr sz="1500" b="0">
+                          <a:solidFill>
+                            <a:srgbClr val="1A365D"/>
+                          </a:solidFill>
+                        </a:defRPr>
+                      </a:pPr>
+                      <a:r>
+                        <a:t>Dengue_clinical_dataset.csv</a:t>
+                      </a:r>
+                    </a:p>
+                  </a:txBody>
+                  <a:tcPr>
+                    <a:solidFill>
+                      <a:srgbClr val="EBF4FF"/>
+                    </a:solidFill>
+                  </a:tcPr>
+                </a:tc>
+                <a:tc>
+                  <a:txBody>
+                    <a:bodyPr/>
+                    <a:lstStyle/>
+                    <a:p>
+                      <a:pPr>
+                        <a:defRPr sz="1500" b="0">
+                          <a:solidFill>
+                            <a:srgbClr val="1A365D"/>
+                          </a:solidFill>
+                        </a:defRPr>
+                      </a:pPr>
+                      <a:r>
+                        <a:t>results/nmprediction_clinical/</a:t>
+                      </a:r>
+                    </a:p>
+                  </a:txBody>
+                  <a:tcPr>
+                    <a:solidFill>
+                      <a:srgbClr val="EBF4FF"/>
+                    </a:solidFill>
+                  </a:tcPr>
+                </a:tc>
+              </a:tr>
+              <a:tr h="457200">
+                <a:tc>
+                  <a:txBody>
+                    <a:bodyPr/>
+                    <a:lstStyle/>
+                    <a:p>
+                      <a:pPr>
+                        <a:defRPr sz="1500" b="0">
+                          <a:solidFill>
+                            <a:srgbClr val="1A365D"/>
+                          </a:solidFill>
+                        </a:defRPr>
+                      </a:pPr>
+                      <a:r>
+                        <a:t>run_arff_disease_benchmark.py</a:t>
+                      </a:r>
+                    </a:p>
+                  </a:txBody>
+                  <a:tcPr>
+                    <a:solidFill>
+                      <a:srgbClr val="FFFFFF"/>
+                    </a:solidFill>
+                  </a:tcPr>
+                </a:tc>
+                <a:tc>
+                  <a:txBody>
+                    <a:bodyPr/>
+                    <a:lstStyle/>
+                    <a:p>
+                      <a:pPr>
+                        <a:defRPr sz="1500" b="0">
+                          <a:solidFill>
+                            <a:srgbClr val="1A365D"/>
+                          </a:solidFill>
+                        </a:defRPr>
+                      </a:pPr>
+                      <a:r>
+                        <a:t>11 disease ARFFs</a:t>
+                      </a:r>
+                    </a:p>
+                  </a:txBody>
+                  <a:tcPr>
+                    <a:solidFill>
+                      <a:srgbClr val="FFFFFF"/>
+                    </a:solidFill>
+                  </a:tcPr>
+                </a:tc>
+                <a:tc>
+                  <a:txBody>
+                    <a:bodyPr/>
+                    <a:lstStyle/>
+                    <a:p>
+                      <a:pPr>
+                        <a:defRPr sz="1500" b="0">
+                          <a:solidFill>
+                            <a:srgbClr val="1A365D"/>
+                          </a:solidFill>
+                        </a:defRPr>
+                      </a:pPr>
+                      <a:r>
+                        <a:t>results/arff_disease_comparison/</a:t>
+                      </a:r>
+                    </a:p>
+                  </a:txBody>
+                  <a:tcPr>
+                    <a:solidFill>
+                      <a:srgbClr val="FFFFFF"/>
+                    </a:solidFill>
+                  </a:tcPr>
+                </a:tc>
+              </a:tr>
+              <a:tr h="457200">
+                <a:tc>
+                  <a:txBody>
+                    <a:bodyPr/>
+                    <a:lstStyle/>
+                    <a:p>
+                      <a:pPr>
+                        <a:defRPr sz="1500" b="0">
+                          <a:solidFill>
+                            <a:srgbClr val="1A365D"/>
+                          </a:solidFill>
+                        </a:defRPr>
+                      </a:pPr>
+                      <a:r>
+                        <a:t>run_imputation_comparison.py</a:t>
+                      </a:r>
+                    </a:p>
+                  </a:txBody>
+                  <a:tcPr>
+                    <a:solidFill>
+                      <a:srgbClr val="EBF4FF"/>
+                    </a:solidFill>
+                  </a:tcPr>
+                </a:tc>
+                <a:tc>
+                  <a:txBody>
+                    <a:bodyPr/>
+                    <a:lstStyle/>
+                    <a:p>
+                      <a:pPr>
+                        <a:defRPr sz="1500" b="0">
+                          <a:solidFill>
+                            <a:srgbClr val="1A365D"/>
+                          </a:solidFill>
+                        </a:defRPr>
+                      </a:pPr>
+                      <a:r>
+                        <a:t>dataset.csv + MCAR</a:t>
+                      </a:r>
+                    </a:p>
+                  </a:txBody>
+                  <a:tcPr>
+                    <a:solidFill>
+                      <a:srgbClr val="EBF4FF"/>
+                    </a:solidFill>
+                  </a:tcPr>
+                </a:tc>
+                <a:tc>
+                  <a:txBody>
+                    <a:bodyPr/>
+                    <a:lstStyle/>
+                    <a:p>
+                      <a:pPr>
+                        <a:defRPr sz="1500" b="0">
+                          <a:solidFill>
+                            <a:srgbClr val="1A365D"/>
+                          </a:solidFill>
+                        </a:defRPr>
+                      </a:pPr>
+                      <a:r>
+                        <a:t>results/imputation_dataset_csv/</a:t>
+                      </a:r>
+                    </a:p>
+                  </a:txBody>
+                  <a:tcPr>
+                    <a:solidFill>
+                      <a:srgbClr val="EBF4FF"/>
+                    </a:solidFill>
+                  </a:tcPr>
+                </a:tc>
+              </a:tr>
+              <a:tr h="457200">
+                <a:tc>
+                  <a:txBody>
+                    <a:bodyPr/>
+                    <a:lstStyle/>
+                    <a:p>
+                      <a:pPr>
+                        <a:defRPr sz="1500" b="0">
+                          <a:solidFill>
+                            <a:srgbClr val="1A365D"/>
+                          </a:solidFill>
+                        </a:defRPr>
+                      </a:pPr>
+                      <a:r>
+                        <a:t>run_missforest_comparison.py</a:t>
+                      </a:r>
+                    </a:p>
+                  </a:txBody>
+                  <a:tcPr>
+                    <a:solidFill>
+                      <a:srgbClr val="FFFFFF"/>
+                    </a:solidFill>
+                  </a:tcPr>
+                </a:tc>
+                <a:tc>
+                  <a:txBody>
+                    <a:bodyPr/>
+                    <a:lstStyle/>
+                    <a:p>
+                      <a:pPr>
+                        <a:defRPr sz="1500" b="0">
+                          <a:solidFill>
+                            <a:srgbClr val="1A365D"/>
+                          </a:solidFill>
+                        </a:defRPr>
+                      </a:pPr>
+                      <a:r>
+                        <a:t>Iris + 20% MCAR</a:t>
+                      </a:r>
+                    </a:p>
+                  </a:txBody>
+                  <a:tcPr>
+                    <a:solidFill>
+                      <a:srgbClr val="FFFFFF"/>
+                    </a:solidFill>
+                  </a:tcPr>
+                </a:tc>
+                <a:tc>
+                  <a:txBody>
+                    <a:bodyPr/>
+                    <a:lstStyle/>
+                    <a:p>
+                      <a:pPr>
+                        <a:defRPr sz="1500" b="0">
+                          <a:solidFill>
+                            <a:srgbClr val="1A365D"/>
+                          </a:solidFill>
+                        </a:defRPr>
+                      </a:pPr>
+                      <a:r>
+                        <a:t>results/missforest_comparison/</a:t>
+                      </a:r>
+                    </a:p>
+                  </a:txBody>
+                  <a:tcPr>
+                    <a:solidFill>
+                      <a:srgbClr val="FFFFFF"/>
+                    </a:solidFill>
+                  </a:tcPr>
+                </a:tc>
+              </a:tr>
+              <a:tr h="457200">
+                <a:tc>
+                  <a:txBody>
+                    <a:bodyPr/>
+                    <a:lstStyle/>
+                    <a:p>
+                      <a:pPr>
+                        <a:defRPr sz="1500" b="0">
+                          <a:solidFill>
+                            <a:srgbClr val="1A365D"/>
+                          </a:solidFill>
+                        </a:defRPr>
+                      </a:pPr>
+                      <a:r>
+                        <a:t>run_holdout_imputation_prediction.py</a:t>
+                      </a:r>
+                    </a:p>
+                  </a:txBody>
+                  <a:tcPr>
+                    <a:solidFill>
+                      <a:srgbClr val="EBF4FF"/>
+                    </a:solidFill>
+                  </a:tcPr>
+                </a:tc>
+                <a:tc>
+                  <a:txBody>
+                    <a:bodyPr/>
+                    <a:lstStyle/>
+                    <a:p>
+                      <a:pPr>
+                        <a:defRPr sz="1500" b="0">
+                          <a:solidFill>
+                            <a:srgbClr val="1A365D"/>
+                          </a:solidFill>
+                        </a:defRPr>
+                      </a:pPr>
+                      <a:r>
+                        <a:t>5 dengue sets + 11 ARFFs</a:t>
+                      </a:r>
+                    </a:p>
+                  </a:txBody>
+                  <a:tcPr>
+                    <a:solidFill>
+                      <a:srgbClr val="EBF4FF"/>
+                    </a:solidFill>
+                  </a:tcPr>
+                </a:tc>
+                <a:tc>
+                  <a:txBody>
+                    <a:bodyPr/>
+                    <a:lstStyle/>
+                    <a:p>
+                      <a:pPr>
+                        <a:defRPr sz="1500" b="0">
+                          <a:solidFill>
+                            <a:srgbClr val="1A365D"/>
+                          </a:solidFill>
+                        </a:defRPr>
+                      </a:pPr>
+                      <a:r>
+                        <a:t>results/holdout_imputation_prediction/</a:t>
+                      </a:r>
+                    </a:p>
+                  </a:txBody>
+                  <a:tcPr>
+                    <a:solidFill>
+                      <a:srgbClr val="EBF4FF"/>
+                    </a:solidFill>
+                  </a:tcPr>
+                </a:tc>
+              </a:tr>
+              <a:tr h="457200">
+                <a:tc>
+                  <a:txBody>
+                    <a:bodyPr/>
+                    <a:lstStyle/>
+                    <a:p>
+                      <a:pPr>
+                        <a:defRPr sz="1500" b="0">
+                          <a:solidFill>
+                            <a:srgbClr val="1A365D"/>
+                          </a:solidFill>
+                        </a:defRPr>
+                      </a:pPr>
+                      <a:r>
+                        <a:t>build_comparison_pdf.py</a:t>
+                      </a:r>
+                    </a:p>
+                  </a:txBody>
+                  <a:tcPr>
+                    <a:solidFill>
+                      <a:srgbClr val="FFFFFF"/>
+                    </a:solidFill>
+                  </a:tcPr>
+                </a:tc>
+                <a:tc>
+                  <a:txBody>
+                    <a:bodyPr/>
+                    <a:lstStyle/>
+                    <a:p>
+                      <a:pPr>
+                        <a:defRPr sz="1500" b="0">
+                          <a:solidFill>
+                            <a:srgbClr val="1A365D"/>
+                          </a:solidFill>
+                        </a:defRPr>
+                      </a:pPr>
+                      <a:r>
+                        <a:t>all results</a:t>
+                      </a:r>
+                    </a:p>
+                  </a:txBody>
+                  <a:tcPr>
+                    <a:solidFill>
+                      <a:srgbClr val="FFFFFF"/>
+                    </a:solidFill>
+                  </a:tcPr>
+                </a:tc>
+                <a:tc>
+                  <a:txBody>
+                    <a:bodyPr/>
+                    <a:lstStyle/>
+                    <a:p>
+                      <a:pPr>
+                        <a:defRPr sz="1500" b="0">
+                          <a:solidFill>
+                            <a:srgbClr val="1A365D"/>
+                          </a:solidFill>
+                        </a:defRPr>
+                      </a:pPr>
+                      <a:r>
+                        <a:t>Performance comparison PDF (docs/)</a:t>
+                      </a:r>
+                    </a:p>
+                  </a:txBody>
+                  <a:tcPr>
+                    <a:solidFill>
+                      <a:srgbClr val="FFFFFF"/>
+                    </a:solidFill>
+                  </a:tcPr>
+                </a:tc>
+              </a:tr>
+              <a:tr h="457200">
+                <a:tc>
+                  <a:txBody>
+                    <a:bodyPr/>
+                    <a:lstStyle/>
+                    <a:p>
+                      <a:pPr>
+                        <a:defRPr sz="1500" b="0">
+                          <a:solidFill>
+                            <a:srgbClr val="1A365D"/>
+                          </a:solidFill>
+                        </a:defRPr>
+                      </a:pPr>
+                      <a:r>
+                        <a:t>build_holdout_comparison_pdf.py</a:t>
+                      </a:r>
+                    </a:p>
+                  </a:txBody>
+                  <a:tcPr>
+                    <a:solidFill>
+                      <a:srgbClr val="EBF4FF"/>
+                    </a:solidFill>
+                  </a:tcPr>
+                </a:tc>
+                <a:tc>
+                  <a:txBody>
+                    <a:bodyPr/>
+                    <a:lstStyle/>
+                    <a:p>
+                      <a:pPr>
+                        <a:defRPr sz="1500" b="0">
+                          <a:solidFill>
+                            <a:srgbClr val="1A365D"/>
+                          </a:solidFill>
+                        </a:defRPr>
+                      </a:pPr>
+                      <a:r>
+                        <a:t>hold-out results</a:t>
+                      </a:r>
+                    </a:p>
+                  </a:txBody>
+                  <a:tcPr>
+                    <a:solidFill>
+                      <a:srgbClr val="EBF4FF"/>
+                    </a:solidFill>
+                  </a:tcPr>
+                </a:tc>
+                <a:tc>
+                  <a:txBody>
+                    <a:bodyPr/>
+                    <a:lstStyle/>
+                    <a:p>
+                      <a:pPr>
+                        <a:defRPr sz="1500" b="0">
+                          <a:solidFill>
+                            <a:srgbClr val="1A365D"/>
+                          </a:solidFill>
+                        </a:defRPr>
+                      </a:pPr>
+                      <a:r>
+                        <a:t>Imputation / prediction hold-out PDF (docs/)</a:t>
+                      </a:r>
+                    </a:p>
+                  </a:txBody>
+                  <a:tcPr>
+                    <a:solidFill>
+                      <a:srgbClr val="EBF4FF"/>
+                    </a:solidFill>
+                  </a:tcPr>
+                </a:tc>
+              </a:tr>
+            </a:tbl>
+          </a:graphicData>
+        </a:graphic>
+      </p:graphicFrame>
       <p:sp>
         <p:nvSpPr>
           <p:cNvPr id="4" name="TextBox 3"/>
-          <p:cNvSpPr txBox="1"/>
-          <p:nvPr/>
-        </p:nvSpPr>
-        <p:spPr>
-          <a:xfrm>
-            <a:off x="274320" y="6080760"/>
-            <a:ext cx="11643055" cy="457200"/>
-          </a:xfrm>
-          <a:prstGeom prst="rect">
-            <a:avLst/>
-          </a:prstGeom>
-          <a:noFill/>
-        </p:spPr>
-        <p:txBody>
-          <a:bodyPr wrap="square">
-            <a:spAutoFit/>
-          </a:bodyPr>
-          <a:lstStyle/>
-          <a:p>
-            <a:pPr algn="ctr"/>
-            <a:r>
-              <a:rPr sz="1400" i="1">
-                <a:solidFill>
-                  <a:srgbClr val="4A5568"/>
-                </a:solidFill>
-              </a:rPr>
-              <a:t>GitHub Actions on every push and pull request; a green push to main cuts a semver release.</a:t>
-            </a:r>
-          </a:p>
-        </p:txBody>
-      </p:sp>
-      <p:sp>
-        <p:nvSpPr>
-          <p:cNvPr id="5" name="TextBox 4"/>
           <p:cNvSpPr txBox="1"/>
           <p:nvPr/>
         </p:nvSpPr>
@@ -5657,21 +5870,53 @@
                   <a:srgbClr val="FFFFFF"/>
                 </a:solidFill>
               </a:rPr>
-              <a:t>Design decisions and extension points</a:t>
-            </a:r>
-          </a:p>
-        </p:txBody>
-      </p:sp>
-      <p:sp>
-        <p:nvSpPr>
-          <p:cNvPr id="3" name="TextBox 2"/>
+              <a:t>CI/CD</a:t>
+            </a:r>
+            <a:r>
+              <a:rPr sz="1600">
+                <a:solidFill>
+                  <a:srgbClr val="BEE3F8"/>
+                </a:solidFill>
+              </a:rPr>
+              <a:t>   GitHub Actions</a:t>
+            </a:r>
+          </a:p>
+        </p:txBody>
+      </p:sp>
+      <p:pic>
+        <p:nvPicPr>
+          <p:cNvPr id="3" name="Picture 2" descr="08-ci-cd.png"/>
+          <p:cNvPicPr>
+            <a:picLocks noChangeAspect="1"/>
+          </p:cNvPicPr>
+          <p:nvPr/>
+        </p:nvPicPr>
+        <p:blipFill>
+          <a:blip r:embed="rId2"/>
+          <a:stretch>
+            <a:fillRect/>
+          </a:stretch>
+        </p:blipFill>
+        <p:spPr>
+          <a:xfrm>
+            <a:off x="274320" y="2390609"/>
+            <a:ext cx="11643055" cy="2168221"/>
+          </a:xfrm>
+          <a:prstGeom prst="rect">
+            <a:avLst/>
+          </a:prstGeom>
+        </p:spPr>
+      </p:pic>
+      <p:sp>
+        <p:nvSpPr>
+          <p:cNvPr id="4" name="TextBox 3"/>
           <p:cNvSpPr txBox="1"/>
           <p:nvPr/>
         </p:nvSpPr>
         <p:spPr>
           <a:xfrm>
-            <a:off x="548640" y="1188720"/>
-            <a:ext cx="11094415" cy="4937760"/>
+            <a:off x="274320" y="6080760"/>
+            <a:ext cx="11643055" cy="457200"/>
           </a:xfrm>
           <a:prstGeom prst="rect">
             <a:avLst/>
@@ -5684,130 +5929,21 @@
           </a:bodyPr>
           <a:lstStyle/>
           <a:p>
-            <a:pPr>
-              <a:spcAft>
-                <a:spcPts val="1000"/>
-              </a:spcAft>
-            </a:pPr>
-            <a:r>
-              <a:rPr sz="2400">
-                <a:solidFill>
-                  <a:srgbClr val="1A365D"/>
+            <a:pPr algn="ctr"/>
+            <a:r>
+              <a:rPr sz="1400" i="1">
+                <a:solidFill>
+                  <a:srgbClr val="4A5568"/>
                 </a:solidFill>
               </a:rPr>
-              <a:t>•  NMI kept as an external library behind nmi_support</a:t>
-            </a:r>
-          </a:p>
-          <a:p>
-            <a:pPr lvl="1">
-              <a:spcAft>
-                <a:spcPts val="1000"/>
-              </a:spcAft>
-            </a:pPr>
-            <a:r>
-              <a:rPr sz="2100">
-                <a:solidFill>
-                  <a:srgbClr val="4A5568"/>
-                </a:solidFill>
-              </a:rPr>
-              <a:t>      –  Swap the checkout with NMI_ROOT; no code changes</a:t>
-            </a:r>
-          </a:p>
-          <a:p>
-            <a:pPr>
-              <a:spcAft>
-                <a:spcPts val="1000"/>
-              </a:spcAft>
-            </a:pPr>
-            <a:r>
-              <a:rPr sz="2400">
-                <a:solidFill>
-                  <a:srgbClr val="1A365D"/>
-                </a:solidFill>
-              </a:rPr>
-              <a:t>•  Pluggable learners through factories (baselines, classifiers)</a:t>
-            </a:r>
-          </a:p>
-          <a:p>
-            <a:pPr lvl="1">
-              <a:spcAft>
-                <a:spcPts val="1000"/>
-              </a:spcAft>
-            </a:pPr>
-            <a:r>
-              <a:rPr sz="2100">
-                <a:solidFill>
-                  <a:srgbClr val="4A5568"/>
-                </a:solidFill>
-              </a:rPr>
-              <a:t>      –  GA wrapper can evaluate with ADT, SVM or decision tree</a:t>
-            </a:r>
-          </a:p>
-          <a:p>
-            <a:pPr>
-              <a:spcAft>
-                <a:spcPts val="1000"/>
-              </a:spcAft>
-            </a:pPr>
-            <a:r>
-              <a:rPr sz="2400">
-                <a:solidFill>
-                  <a:srgbClr val="1A365D"/>
-                </a:solidFill>
-              </a:rPr>
-              <a:t>•  Disease-agnostic data layer</a:t>
-            </a:r>
-          </a:p>
-          <a:p>
-            <a:pPr lvl="1">
-              <a:spcAft>
-                <a:spcPts val="1000"/>
-              </a:spcAft>
-            </a:pPr>
-            <a:r>
-              <a:rPr sz="2100">
-                <a:solidFill>
-                  <a:srgbClr val="4A5568"/>
-                </a:solidFill>
-              </a:rPr>
-              <a:t>      –  New datasets: add a CSV/ARFF loader, reuse run_dataset_comparison</a:t>
-            </a:r>
-          </a:p>
-          <a:p>
-            <a:pPr>
-              <a:spcAft>
-                <a:spcPts val="1000"/>
-              </a:spcAft>
-            </a:pPr>
-            <a:r>
-              <a:rPr sz="2400">
-                <a:solidFill>
-                  <a:srgbClr val="1A365D"/>
-                </a:solidFill>
-              </a:rPr>
-              <a:t>•  Reproducibility</a:t>
-            </a:r>
-          </a:p>
-          <a:p>
-            <a:pPr lvl="1">
-              <a:spcAft>
-                <a:spcPts val="1000"/>
-              </a:spcAft>
-            </a:pPr>
-            <a:r>
-              <a:rPr sz="2100">
-                <a:solidFill>
-                  <a:srgbClr val="4A5568"/>
-                </a:solidFill>
-              </a:rPr>
-              <a:t>      –  Fixed random seeds, scripted runs, PDF and diagrams regenerated from source</a:t>
-            </a:r>
-          </a:p>
-        </p:txBody>
-      </p:sp>
-      <p:sp>
-        <p:nvSpPr>
-          <p:cNvPr id="4" name="TextBox 3"/>
+              <a:t>GitHub Actions on every push and pull request; a green push to main cuts a semver release.</a:t>
+            </a:r>
+          </a:p>
+        </p:txBody>
+      </p:sp>
+      <p:sp>
+        <p:nvSpPr>
+          <p:cNvPr id="5" name="TextBox 4"/>
           <p:cNvSpPr txBox="1"/>
           <p:nvPr/>
         </p:nvSpPr>
@@ -5903,7 +6039,7 @@
                   <a:srgbClr val="FFFFFF"/>
                 </a:solidFill>
               </a:rPr>
-              <a:t>Running and regenerating</a:t>
+              <a:t>Design decisions and extension points</a:t>
             </a:r>
           </a:p>
         </p:txBody>
@@ -5917,7 +6053,7 @@
         <p:spPr>
           <a:xfrm>
             <a:off x="548640" y="1188720"/>
-            <a:ext cx="11094415" cy="4572000"/>
+            <a:ext cx="11094415" cy="4937760"/>
           </a:xfrm>
           <a:prstGeom prst="rect">
             <a:avLst/>
@@ -5936,13 +6072,27 @@
               </a:spcAft>
             </a:pPr>
             <a:r>
-              <a:rPr sz="1800">
+              <a:rPr sz="2400">
                 <a:solidFill>
                   <a:srgbClr val="1A365D"/>
                 </a:solidFill>
-                <a:latin typeface="Courier New"/>
               </a:rPr>
-              <a:t>source .venv/bin/activate</a:t>
+              <a:t>•  NMI kept as an external library behind nmi_support</a:t>
+            </a:r>
+          </a:p>
+          <a:p>
+            <a:pPr lvl="1">
+              <a:spcAft>
+                <a:spcPts val="1000"/>
+              </a:spcAft>
+            </a:pPr>
+            <a:r>
+              <a:rPr sz="2100">
+                <a:solidFill>
+                  <a:srgbClr val="4A5568"/>
+                </a:solidFill>
+              </a:rPr>
+              <a:t>      –  Swap the checkout with NMI_ROOT; no code changes</a:t>
             </a:r>
           </a:p>
           <a:p>
@@ -5952,13 +6102,27 @@
               </a:spcAft>
             </a:pPr>
             <a:r>
-              <a:rPr sz="1800">
+              <a:rPr sz="2400">
                 <a:solidFill>
                   <a:srgbClr val="1A365D"/>
                 </a:solidFill>
-                <a:latin typeface="Courier New"/>
               </a:rPr>
-              <a:t>python scripts/run_nm_comparison.py            # dengue.csv experiment</a:t>
+              <a:t>•  Pluggable learners through factories (baselines, classifiers)</a:t>
+            </a:r>
+          </a:p>
+          <a:p>
+            <a:pPr lvl="1">
+              <a:spcAft>
+                <a:spcPts val="1000"/>
+              </a:spcAft>
+            </a:pPr>
+            <a:r>
+              <a:rPr sz="2100">
+                <a:solidFill>
+                  <a:srgbClr val="4A5568"/>
+                </a:solidFill>
+              </a:rPr>
+              <a:t>      –  GA wrapper can evaluate with ADT, SVM or decision tree</a:t>
             </a:r>
           </a:p>
           <a:p>
@@ -5968,13 +6132,27 @@
               </a:spcAft>
             </a:pPr>
             <a:r>
-              <a:rPr sz="1800">
+              <a:rPr sz="2400">
                 <a:solidFill>
                   <a:srgbClr val="1A365D"/>
                 </a:solidFill>
-                <a:latin typeface="Courier New"/>
               </a:rPr>
-              <a:t>python scripts/run_arff_disease_benchmark.py   # multi-disease ARFFs</a:t>
+              <a:t>•  Disease-agnostic data layer</a:t>
+            </a:r>
+          </a:p>
+          <a:p>
+            <a:pPr lvl="1">
+              <a:spcAft>
+                <a:spcPts val="1000"/>
+              </a:spcAft>
+            </a:pPr>
+            <a:r>
+              <a:rPr sz="2100">
+                <a:solidFill>
+                  <a:srgbClr val="4A5568"/>
+                </a:solidFill>
+              </a:rPr>
+              <a:t>      –  New datasets: add a CSV/ARFF loader, reuse run_dataset_comparison</a:t>
             </a:r>
           </a:p>
           <a:p>
@@ -5984,61 +6162,27 @@
               </a:spcAft>
             </a:pPr>
             <a:r>
-              <a:rPr sz="1800">
+              <a:rPr sz="2400">
                 <a:solidFill>
                   <a:srgbClr val="1A365D"/>
                 </a:solidFill>
-                <a:latin typeface="Courier New"/>
               </a:rPr>
-              <a:t>python scripts/build_comparison_pdf.py         # performance report</a:t>
-            </a:r>
-          </a:p>
-          <a:p>
-            <a:pPr>
+              <a:t>•  Reproducibility</a:t>
+            </a:r>
+          </a:p>
+          <a:p>
+            <a:pPr lvl="1">
               <a:spcAft>
                 <a:spcPts val="1000"/>
               </a:spcAft>
             </a:pPr>
             <a:r>
-              <a:rPr sz="1800">
-                <a:solidFill>
-                  <a:srgbClr val="1A365D"/>
-                </a:solidFill>
-                <a:latin typeface="Courier New"/>
+              <a:rPr sz="2100">
+                <a:solidFill>
+                  <a:srgbClr val="4A5568"/>
+                </a:solidFill>
               </a:rPr>
-              <a:t>python scripts/render_architecture_diagrams.py # diagrams from ARCHITECTURE.md</a:t>
-            </a:r>
-          </a:p>
-          <a:p>
-            <a:pPr>
-              <a:spcAft>
-                <a:spcPts val="1000"/>
-              </a:spcAft>
-            </a:pPr>
-            <a:r>
-              <a:rPr sz="1800">
-                <a:solidFill>
-                  <a:srgbClr val="1A365D"/>
-                </a:solidFill>
-                <a:latin typeface="Courier New"/>
-              </a:rPr>
-              <a:t>python scripts/build_architecture_slides.py    # this deck</a:t>
-            </a:r>
-          </a:p>
-          <a:p>
-            <a:pPr>
-              <a:spcAft>
-                <a:spcPts val="1000"/>
-              </a:spcAft>
-            </a:pPr>
-            <a:r>
-              <a:rPr sz="1800">
-                <a:solidFill>
-                  <a:srgbClr val="1A365D"/>
-                </a:solidFill>
-                <a:latin typeface="Courier New"/>
-              </a:rPr>
-              <a:t>bash scripts/ci_local.sh                       # CI gates before push</a:t>
+              <a:t>      –  Fixed random seeds, scripted runs, PDF and diagrams regenerated from source</a:t>
             </a:r>
           </a:p>
         </p:txBody>
@@ -6085,7 +6229,7 @@
 </p:sld>
 </file>
 
-<file path=ppt/slides/slide2.xml><?xml version="1.0" encoding="utf-8"?>
+<file path=ppt/slides/slide15.xml><?xml version="1.0" encoding="utf-8"?>
 <p:sld xmlns:a="http://schemas.openxmlformats.org/drawingml/2006/main" xmlns:p="http://schemas.openxmlformats.org/presentationml/2006/main" xmlns:r="http://schemas.openxmlformats.org/officeDocument/2006/relationships">
   <p:cSld>
     <p:spTree>
@@ -6141,7 +6285,7 @@
                   <a:srgbClr val="FFFFFF"/>
                 </a:solidFill>
               </a:rPr>
-              <a:t>What DengueCAD does</a:t>
+              <a:t>Running and regenerating</a:t>
             </a:r>
           </a:p>
         </p:txBody>
@@ -6155,7 +6299,7 @@
         <p:spPr>
           <a:xfrm>
             <a:off x="548640" y="1188720"/>
-            <a:ext cx="11094415" cy="4937760"/>
+            <a:ext cx="11094415" cy="4572000"/>
           </a:xfrm>
           <a:prstGeom prst="rect">
             <a:avLst/>
@@ -6174,42 +6318,13 @@
               </a:spcAft>
             </a:pPr>
             <a:r>
-              <a:rPr sz="2400">
+              <a:rPr sz="1800">
                 <a:solidFill>
                   <a:srgbClr val="1A365D"/>
                 </a:solidFill>
+                <a:latin typeface="Courier New"/>
               </a:rPr>
-              <a:t>•  Implements NMPrediction (Rao &amp; Kumar, IEEE TITB 2012)</a:t>
-            </a:r>
-          </a:p>
-          <a:p>
-            <a:pPr lvl="1">
-              <a:spcAft>
-                <a:spcPts val="1000"/>
-              </a:spcAft>
-            </a:pPr>
-            <a:r>
-              <a:rPr sz="2100">
-                <a:solidFill>
-                  <a:srgbClr val="4A5568"/>
-                </a:solidFill>
-              </a:rPr>
-              <a:t>      –  NMI imputation → GA wrapper feature selection → stratified 10-fold ADT</a:t>
-            </a:r>
-          </a:p>
-          <a:p>
-            <a:pPr lvl="1">
-              <a:spcAft>
-                <a:spcPts val="1000"/>
-              </a:spcAft>
-            </a:pPr>
-            <a:r>
-              <a:rPr sz="2100">
-                <a:solidFill>
-                  <a:srgbClr val="4A5568"/>
-                </a:solidFill>
-              </a:rPr>
-              <a:t>      –  Reports Accuracy, AUC, Sensitivity (SE), Specificity (SP)</a:t>
+              <a:t>source .venv/bin/activate</a:t>
             </a:r>
           </a:p>
           <a:p>
@@ -6219,27 +6334,13 @@
               </a:spcAft>
             </a:pPr>
             <a:r>
-              <a:rPr sz="2400">
+              <a:rPr sz="1800">
                 <a:solidFill>
                   <a:srgbClr val="1A365D"/>
                 </a:solidFill>
+                <a:latin typeface="Courier New"/>
               </a:rPr>
-              <a:t>•  Compares NM against C4.5, Logistic Regression (LOR) and SVM (RBF)</a:t>
-            </a:r>
-          </a:p>
-          <a:p>
-            <a:pPr lvl="1">
-              <a:spcAft>
-                <a:spcPts val="1000"/>
-              </a:spcAft>
-            </a:pPr>
-            <a:r>
-              <a:rPr sz="2100">
-                <a:solidFill>
-                  <a:srgbClr val="4A5568"/>
-                </a:solidFill>
-              </a:rPr>
-              <a:t>      –  Table I performance · Table II Wilcoxon test · Table III influential features</a:t>
+              <a:t>python scripts/run_nm_comparison.py                 # dengue.csv experiment</a:t>
             </a:r>
           </a:p>
           <a:p>
@@ -6249,12 +6350,13 @@
               </a:spcAft>
             </a:pPr>
             <a:r>
-              <a:rPr sz="2400">
+              <a:rPr sz="1800">
                 <a:solidFill>
                   <a:srgbClr val="1A365D"/>
                 </a:solidFill>
+                <a:latin typeface="Courier New"/>
               </a:rPr>
-              <a:t>•  Benchmarks imputation: NMI vs MissForest, MICE, kNN, Mean/Median/Mode</a:t>
+              <a:t>python scripts/run_arff_disease_benchmark.py        # multi-disease ARFFs</a:t>
             </a:r>
           </a:p>
           <a:p>
@@ -6264,12 +6366,13 @@
               </a:spcAft>
             </a:pPr>
             <a:r>
-              <a:rPr sz="2400">
+              <a:rPr sz="1800">
                 <a:solidFill>
                   <a:srgbClr val="1A365D"/>
                 </a:solidFill>
+                <a:latin typeface="Courier New"/>
               </a:rPr>
-              <a:t>•  Disease-agnostic: dengue CSVs plus 11 KEEL / Weka ARFF disease datasets</a:t>
+              <a:t>python scripts/run_holdout_imputation_prediction.py # hold-out experiment</a:t>
             </a:r>
           </a:p>
           <a:p>
@@ -6279,12 +6382,77 @@
               </a:spcAft>
             </a:pPr>
             <a:r>
-              <a:rPr sz="2400">
+              <a:rPr sz="1800">
                 <a:solidFill>
                   <a:srgbClr val="1A365D"/>
                 </a:solidFill>
+                <a:latin typeface="Courier New"/>
               </a:rPr>
-              <a:t>•  Reproducible: scripted experiments, generated PDF report, CI on every push</a:t>
+              <a:t>python scripts/build_comparison_pdf.py              # performance report</a:t>
+            </a:r>
+          </a:p>
+          <a:p>
+            <a:pPr>
+              <a:spcAft>
+                <a:spcPts val="1000"/>
+              </a:spcAft>
+            </a:pPr>
+            <a:r>
+              <a:rPr sz="1800">
+                <a:solidFill>
+                  <a:srgbClr val="1A365D"/>
+                </a:solidFill>
+                <a:latin typeface="Courier New"/>
+              </a:rPr>
+              <a:t>python scripts/build_holdout_comparison_pdf.py      # hold-out report</a:t>
+            </a:r>
+          </a:p>
+          <a:p>
+            <a:pPr>
+              <a:spcAft>
+                <a:spcPts val="1000"/>
+              </a:spcAft>
+            </a:pPr>
+            <a:r>
+              <a:rPr sz="1800">
+                <a:solidFill>
+                  <a:srgbClr val="1A365D"/>
+                </a:solidFill>
+                <a:latin typeface="Courier New"/>
+              </a:rPr>
+              <a:t>python scripts/render_architecture_diagrams.py      # diagrams</a:t>
+            </a:r>
+          </a:p>
+          <a:p>
+            <a:pPr>
+              <a:spcAft>
+                <a:spcPts val="1000"/>
+              </a:spcAft>
+            </a:pPr>
+            <a:r>
+              <a:rPr sz="1800">
+                <a:solidFill>
+                  <a:srgbClr val="1A365D"/>
+                </a:solidFill>
+                <a:latin typeface="Courier New"/>
+              </a:rPr>
+              <a:t>python scripts/build_architecture_slides.py --pdf   # this deck</a:t>
+            </a:r>
+          </a:p>
+          <a:p>
+            <a:pPr>
+              <a:spcAft>
+                <a:spcPts val="1000"/>
+              </a:spcAft>
+            </a:pPr>
+            <a:r>
+              <a:rPr sz="1800">
+                <a:solidFill>
+                  <a:srgbClr val="1A365D"/>
+                </a:solidFill>
+                <a:latin typeface="Courier New"/>
+              </a:rPr>
+              <a:t>bash scripts/ci_local.sh                            # CI gates before push</a:t>
             </a:r>
           </a:p>
         </p:txBody>
@@ -6318,7 +6486,7 @@
                   <a:srgbClr val="4A5568"/>
                 </a:solidFill>
               </a:rPr>
-              <a:t>DengueCAD architecture  ·  2</a:t>
+              <a:t>DengueCAD architecture  ·  15</a:t>
             </a:r>
           </a:p>
         </p:txBody>
@@ -6331,7 +6499,7 @@
 </p:sld>
 </file>
 
-<file path=ppt/slides/slide3.xml><?xml version="1.0" encoding="utf-8"?>
+<file path=ppt/slides/slide2.xml><?xml version="1.0" encoding="utf-8"?>
 <p:sld xmlns:a="http://schemas.openxmlformats.org/drawingml/2006/main" xmlns:p="http://schemas.openxmlformats.org/presentationml/2006/main" xmlns:r="http://schemas.openxmlformats.org/officeDocument/2006/relationships">
   <p:cSld>
     <p:spTree>
@@ -6387,6 +6555,267 @@
                   <a:srgbClr val="FFFFFF"/>
                 </a:solidFill>
               </a:rPr>
+              <a:t>What DengueCAD does</a:t>
+            </a:r>
+          </a:p>
+        </p:txBody>
+      </p:sp>
+      <p:sp>
+        <p:nvSpPr>
+          <p:cNvPr id="3" name="TextBox 2"/>
+          <p:cNvSpPr txBox="1"/>
+          <p:nvPr/>
+        </p:nvSpPr>
+        <p:spPr>
+          <a:xfrm>
+            <a:off x="548640" y="1188720"/>
+            <a:ext cx="11094415" cy="4937760"/>
+          </a:xfrm>
+          <a:prstGeom prst="rect">
+            <a:avLst/>
+          </a:prstGeom>
+          <a:noFill/>
+        </p:spPr>
+        <p:txBody>
+          <a:bodyPr wrap="square">
+            <a:spAutoFit/>
+          </a:bodyPr>
+          <a:lstStyle/>
+          <a:p>
+            <a:pPr>
+              <a:spcAft>
+                <a:spcPts val="1000"/>
+              </a:spcAft>
+            </a:pPr>
+            <a:r>
+              <a:rPr sz="2400">
+                <a:solidFill>
+                  <a:srgbClr val="1A365D"/>
+                </a:solidFill>
+              </a:rPr>
+              <a:t>•  Implements NMPrediction (Rao &amp; Kumar, IEEE TITB 2012)</a:t>
+            </a:r>
+          </a:p>
+          <a:p>
+            <a:pPr lvl="1">
+              <a:spcAft>
+                <a:spcPts val="1000"/>
+              </a:spcAft>
+            </a:pPr>
+            <a:r>
+              <a:rPr sz="2100">
+                <a:solidFill>
+                  <a:srgbClr val="4A5568"/>
+                </a:solidFill>
+              </a:rPr>
+              <a:t>      –  NMI imputation → GA wrapper feature selection → stratified 10-fold ADT</a:t>
+            </a:r>
+          </a:p>
+          <a:p>
+            <a:pPr lvl="1">
+              <a:spcAft>
+                <a:spcPts val="1000"/>
+              </a:spcAft>
+            </a:pPr>
+            <a:r>
+              <a:rPr sz="2100">
+                <a:solidFill>
+                  <a:srgbClr val="4A5568"/>
+                </a:solidFill>
+              </a:rPr>
+              <a:t>      –  Reports Accuracy, AUC, Sensitivity (SE), Specificity (SP)</a:t>
+            </a:r>
+          </a:p>
+          <a:p>
+            <a:pPr>
+              <a:spcAft>
+                <a:spcPts val="1000"/>
+              </a:spcAft>
+            </a:pPr>
+            <a:r>
+              <a:rPr sz="2400">
+                <a:solidFill>
+                  <a:srgbClr val="1A365D"/>
+                </a:solidFill>
+              </a:rPr>
+              <a:t>•  Compares NM against C4.5, Logistic Regression (LOR) and SVM (RBF)</a:t>
+            </a:r>
+          </a:p>
+          <a:p>
+            <a:pPr lvl="1">
+              <a:spcAft>
+                <a:spcPts val="1000"/>
+              </a:spcAft>
+            </a:pPr>
+            <a:r>
+              <a:rPr sz="2100">
+                <a:solidFill>
+                  <a:srgbClr val="4A5568"/>
+                </a:solidFill>
+              </a:rPr>
+              <a:t>      –  Table I performance · Table II Wilcoxon test · Table III influential features</a:t>
+            </a:r>
+          </a:p>
+          <a:p>
+            <a:pPr>
+              <a:spcAft>
+                <a:spcPts val="1000"/>
+              </a:spcAft>
+            </a:pPr>
+            <a:r>
+              <a:rPr sz="2400">
+                <a:solidFill>
+                  <a:srgbClr val="1A365D"/>
+                </a:solidFill>
+              </a:rPr>
+              <a:t>•  Benchmarks imputation: NMI vs MissForest, MICE, kNN, Mean/Median/Mode</a:t>
+            </a:r>
+          </a:p>
+          <a:p>
+            <a:pPr lvl="1">
+              <a:spcAft>
+                <a:spcPts val="1000"/>
+              </a:spcAft>
+            </a:pPr>
+            <a:r>
+              <a:rPr sz="2100">
+                <a:solidFill>
+                  <a:srgbClr val="4A5568"/>
+                </a:solidFill>
+              </a:rPr>
+              <a:t>      –  Hold-out experiment: imputation accuracy and hidden-decision prediction accuracy</a:t>
+            </a:r>
+          </a:p>
+          <a:p>
+            <a:pPr>
+              <a:spcAft>
+                <a:spcPts val="1000"/>
+              </a:spcAft>
+            </a:pPr>
+            <a:r>
+              <a:rPr sz="2400">
+                <a:solidFill>
+                  <a:srgbClr val="1A365D"/>
+                </a:solidFill>
+              </a:rPr>
+              <a:t>•  Disease-agnostic: dengue CSVs plus 11 KEEL / Weka ARFF disease datasets</a:t>
+            </a:r>
+          </a:p>
+          <a:p>
+            <a:pPr>
+              <a:spcAft>
+                <a:spcPts val="1000"/>
+              </a:spcAft>
+            </a:pPr>
+            <a:r>
+              <a:rPr sz="2400">
+                <a:solidFill>
+                  <a:srgbClr val="1A365D"/>
+                </a:solidFill>
+              </a:rPr>
+              <a:t>•  Reproducible: scripted experiments, generated PDF report, CI on every push</a:t>
+            </a:r>
+          </a:p>
+        </p:txBody>
+      </p:sp>
+      <p:sp>
+        <p:nvSpPr>
+          <p:cNvPr id="4" name="TextBox 3"/>
+          <p:cNvSpPr txBox="1"/>
+          <p:nvPr/>
+        </p:nvSpPr>
+        <p:spPr>
+          <a:xfrm>
+            <a:off x="274320" y="6492240"/>
+            <a:ext cx="11643055" cy="274320"/>
+          </a:xfrm>
+          <a:prstGeom prst="rect">
+            <a:avLst/>
+          </a:prstGeom>
+          <a:noFill/>
+        </p:spPr>
+        <p:txBody>
+          <a:bodyPr wrap="none">
+            <a:spAutoFit/>
+          </a:bodyPr>
+          <a:lstStyle/>
+          <a:p>
+            <a:pPr algn="r"/>
+            <a:r>
+              <a:rPr sz="1000">
+                <a:solidFill>
+                  <a:srgbClr val="4A5568"/>
+                </a:solidFill>
+              </a:rPr>
+              <a:t>DengueCAD architecture  ·  2</a:t>
+            </a:r>
+          </a:p>
+        </p:txBody>
+      </p:sp>
+    </p:spTree>
+  </p:cSld>
+  <p:clrMapOvr>
+    <a:masterClrMapping/>
+  </p:clrMapOvr>
+</p:sld>
+</file>
+
+<file path=ppt/slides/slide3.xml><?xml version="1.0" encoding="utf-8"?>
+<p:sld xmlns:a="http://schemas.openxmlformats.org/drawingml/2006/main" xmlns:p="http://schemas.openxmlformats.org/presentationml/2006/main" xmlns:r="http://schemas.openxmlformats.org/officeDocument/2006/relationships">
+  <p:cSld>
+    <p:spTree>
+      <p:nvGrpSpPr>
+        <p:cNvPr id="1" name=""/>
+        <p:cNvGrpSpPr/>
+        <p:nvPr/>
+      </p:nvGrpSpPr>
+      <p:grpSpPr/>
+      <p:sp>
+        <p:nvSpPr>
+          <p:cNvPr id="2" name="Rectangle 1"/>
+          <p:cNvSpPr/>
+          <p:nvPr/>
+        </p:nvSpPr>
+        <p:spPr>
+          <a:xfrm>
+            <a:off x="0" y="0"/>
+            <a:ext cx="12191695" cy="822960"/>
+          </a:xfrm>
+          <a:prstGeom prst="rect">
+            <a:avLst/>
+          </a:prstGeom>
+          <a:solidFill>
+            <a:srgbClr val="1A365D"/>
+          </a:solidFill>
+          <a:ln>
+            <a:noFill/>
+          </a:ln>
+        </p:spPr>
+        <p:style>
+          <a:lnRef idx="1">
+            <a:schemeClr val="accent1"/>
+          </a:lnRef>
+          <a:fillRef idx="3">
+            <a:schemeClr val="accent1"/>
+          </a:fillRef>
+          <a:effectRef idx="2">
+            <a:schemeClr val="accent1"/>
+          </a:effectRef>
+          <a:fontRef idx="minor">
+            <a:schemeClr val="lt1"/>
+          </a:fontRef>
+        </p:style>
+        <p:txBody>
+          <a:bodyPr rtlCol="0" anchor="ctr" lIns="274320"/>
+          <a:lstStyle/>
+          <a:p>
+            <a:pPr algn="l"/>
+            <a:r>
+              <a:rPr sz="2800" b="1">
+                <a:solidFill>
+                  <a:srgbClr val="FFFFFF"/>
+                </a:solidFill>
+              </a:rPr>
               <a:t>System overview</a:t>
             </a:r>
           </a:p>
@@ -6408,8 +6837,8 @@
         </p:blipFill>
         <p:spPr>
           <a:xfrm>
-            <a:off x="1188046" y="914400"/>
-            <a:ext cx="9815603" cy="5120640"/>
+            <a:off x="1327936" y="914400"/>
+            <a:ext cx="9535823" cy="5120640"/>
           </a:xfrm>
           <a:prstGeom prst="rect">
             <a:avLst/>
@@ -6976,7 +7405,7 @@
                         </a:defRPr>
                       </a:pPr>
                       <a:r>
-                        <a:t>metrics · comparison</a:t>
+                        <a:t>metrics · comparison · holdout_experiment</a:t>
                       </a:r>
                     </a:p>
                   </a:txBody>
@@ -6999,7 +7428,7 @@
                         </a:defRPr>
                       </a:pPr>
                       <a:r>
-                        <a:t>Accuracy/AUC/SE/SP, Tables I–III, Wilcoxon</a:t>
+                        <a:t>Accuracy/AUC/SE/SP, Tables I–III, Wilcoxon, hold-out protocol</a:t>
                       </a:r>
                     </a:p>
                   </a:txBody>
@@ -7047,7 +7476,7 @@
                         </a:defRPr>
                       </a:pPr>
                       <a:r>
-                        <a:t>scripts/build_comparison_pdf.py</a:t>
+                        <a:t>build_comparison_pdf · build_holdout_comparison_pdf</a:t>
                       </a:r>
                     </a:p>
                   </a:txBody>
@@ -7070,7 +7499,7 @@
                         </a:defRPr>
                       </a:pPr>
                       <a:r>
-                        <a:t>PDF with legend; red = best, green = NM when not best</a:t>
+                        <a:t>Performance and hold-out PDF reports with highlighted best results</a:t>
                       </a:r>
                     </a:p>
                   </a:txBody>
@@ -7542,8 +7971,8 @@
         </p:blipFill>
         <p:spPr>
           <a:xfrm>
-            <a:off x="274320" y="1098586"/>
-            <a:ext cx="11643055" cy="4752267"/>
+            <a:off x="274320" y="1165415"/>
+            <a:ext cx="11643055" cy="4618609"/>
           </a:xfrm>
           <a:prstGeom prst="rect">
             <a:avLst/>

</xml_diff>